<commit_message>
connect-2026: deck v3 exports, 11-slide renders, cue card, phone page, timings for talk+clips (6:44)
</commit_message>
<xml_diff>
--- a/docs/launch/connect-2026/slides.pptx
+++ b/docs/launch/connect-2026/slides.pptx
@@ -15,6 +15,7 @@
     <p:sldId id="263" r:id="rId14"/>
     <p:sldId id="264" r:id="rId15"/>
     <p:sldId id="265" r:id="rId16"/>
+    <p:sldId id="266" r:id="rId17"/>
   </p:sldIdLst>
   <p:sldSz cx="12192000" cy="6858000" type="screen4x3"/>
   <p:notesSz cx="6858000" cy="9144000"/>
@@ -3171,6 +3172,48 @@
 </p:sld>
 </file>
 
+<file path=ppt/slides/slide11.xml><?xml version="1.0" encoding="utf-8"?>
+<p:sld xmlns:a="http://schemas.openxmlformats.org/drawingml/2006/main" xmlns:p="http://schemas.openxmlformats.org/presentationml/2006/main" xmlns:r="http://schemas.openxmlformats.org/officeDocument/2006/relationships">
+  <p:cSld>
+    <p:spTree>
+      <p:nvGrpSpPr>
+        <p:cNvPr id="1" name=""/>
+        <p:cNvGrpSpPr/>
+        <p:nvPr/>
+      </p:nvGrpSpPr>
+      <p:grpSpPr/>
+      <p:pic>
+        <p:nvPicPr>
+          <p:cNvPr id="2" name="Picture 1" descr="slide-11.png"/>
+          <p:cNvPicPr>
+            <a:picLocks noChangeAspect="1"/>
+          </p:cNvPicPr>
+          <p:nvPr/>
+        </p:nvPicPr>
+        <p:blipFill>
+          <a:blip r:embed="rId2"/>
+          <a:stretch>
+            <a:fillRect/>
+          </a:stretch>
+        </p:blipFill>
+        <p:spPr>
+          <a:xfrm>
+            <a:off x="0" y="0"/>
+            <a:ext cx="12192000" cy="6858000"/>
+          </a:xfrm>
+          <a:prstGeom prst="rect">
+            <a:avLst/>
+          </a:prstGeom>
+        </p:spPr>
+      </p:pic>
+    </p:spTree>
+  </p:cSld>
+  <p:clrMapOvr>
+    <a:masterClrMapping/>
+  </p:clrMapOvr>
+</p:sld>
+</file>
+
 <file path=ppt/slides/slide2.xml><?xml version="1.0" encoding="utf-8"?>
 <p:sld xmlns:a="http://schemas.openxmlformats.org/drawingml/2006/main" xmlns:p="http://schemas.openxmlformats.org/presentationml/2006/main" xmlns:r="http://schemas.openxmlformats.org/officeDocument/2006/relationships">
   <p:cSld>
@@ -3375,7 +3418,7 @@
       </p:pic>
       <p:pic>
         <p:nvPicPr>
-          <p:cNvPr id="3" name="squiggle.mp4">
+          <p:cNvPr id="3" name="clip-slide6.mp4">
             <a:hlinkClick r:id="" action="ppaction://media"/>
           </p:cNvPr>
           <p:cNvPicPr>
@@ -3470,11 +3513,66 @@
           </a:prstGeom>
         </p:spPr>
       </p:pic>
+      <p:pic>
+        <p:nvPicPr>
+          <p:cNvPr id="3" name="clip-slide7.mp4">
+            <a:hlinkClick r:id="" action="ppaction://media"/>
+          </p:cNvPr>
+          <p:cNvPicPr>
+            <a:picLocks noChangeAspect="1"/>
+          </p:cNvPicPr>
+          <p:nvPr>
+            <a:videoFile r:link="rId4"/>
+            <p:extLst>
+              <p:ext uri="{DAA4B4D4-6D71-4841-9C94-3DE7FCFB9230}">
+                <p14:media xmlns:p14="http://schemas.microsoft.com/office/powerpoint/2010/main" r:embed="rId3"/>
+              </p:ext>
+            </p:extLst>
+          </p:nvPr>
+        </p:nvPicPr>
+        <p:blipFill>
+          <a:blip r:embed="rId2"/>
+          <a:stretch>
+            <a:fillRect/>
+          </a:stretch>
+        </p:blipFill>
+        <p:spPr>
+          <a:xfrm>
+            <a:off x="609600" y="342900"/>
+            <a:ext cx="10972800" cy="6172200"/>
+          </a:xfrm>
+          <a:prstGeom prst="rect">
+            <a:avLst/>
+          </a:prstGeom>
+        </p:spPr>
+      </p:pic>
     </p:spTree>
   </p:cSld>
   <p:clrMapOvr>
     <a:masterClrMapping/>
   </p:clrMapOvr>
+  <p:timing>
+    <p:tnLst>
+      <p:par>
+        <p:cTn id="1" dur="indefinite" restart="never" nodeType="tmRoot">
+          <p:childTnLst>
+            <p:video>
+              <p:cMediaNode vol="80000">
+                <p:cTn id="2" fill="hold" display="0">
+                  <p:stCondLst>
+                    <p:cond delay="indefinite"/>
+                  </p:stCondLst>
+                </p:cTn>
+                <p:tgtEl>
+                  <p:spTgt spid="3"/>
+                </p:tgtEl>
+              </p:cMediaNode>
+            </p:video>
+          </p:childTnLst>
+        </p:cTn>
+      </p:par>
+    </p:tnLst>
+  </p:timing>
 </p:sld>
 </file>
 

</xml_diff>